<commit_message>
Lineage on all entry points: enable UC lineage in the App; add lineage row to capability matrix
- App now enables UC lineage (trace-back + blast radius) by default: Settings.use_lineage /
  max_lineage_hops (env RCA_USE_LINEAGE), passed to every analyze() call — matching the Skill
  (config use_uc_lineage:true) and CLI (--use-lineage). All three surfaces now attach the
  "Evidence (lineage)" upstream trace-back + downstream blast radius.
- Deck capability matrix: added "UC lineage trace-back + blast radius" (App·CLI·Skill).
</commit_message>
<xml_diff>
--- a/docs/ReconResolve_Leadership.pptx
+++ b/docs/ReconResolve_Leadership.pptx
@@ -4324,30 +4324,30 @@
         </p:nvSpPr>
         <p:spPr>
           <a:xfrm>
-            <a:off x="548640" y="2240280"/>
-            <a:ext cx="2834640" cy="329184"/>
-          </a:xfrm>
-          <a:prstGeom prst="rect">
-            <a:avLst/>
-          </a:prstGeom>
-          <a:noFill/>
-        </p:spPr>
-        <p:txBody>
-          <a:bodyPr wrap="square" anchor="t" lIns="0" rIns="0" tIns="0" bIns="0">
-            <a:spAutoFit/>
-          </a:bodyPr>
-          <a:lstStyle/>
-          <a:p>
-            <a:pPr algn="l">
-              <a:lnSpc>
-                <a:spcPct val="98000"/>
-              </a:lnSpc>
-              <a:spcAft>
-                <a:spcPts val="300"/>
-              </a:spcAft>
-            </a:pPr>
-            <a:r>
-              <a:rPr sz="1050" b="1">
+            <a:off x="548640" y="2212848"/>
+            <a:ext cx="2834640" cy="310896"/>
+          </a:xfrm>
+          <a:prstGeom prst="rect">
+            <a:avLst/>
+          </a:prstGeom>
+          <a:noFill/>
+        </p:spPr>
+        <p:txBody>
+          <a:bodyPr wrap="square" anchor="t" lIns="0" rIns="0" tIns="0" bIns="0">
+            <a:spAutoFit/>
+          </a:bodyPr>
+          <a:lstStyle/>
+          <a:p>
+            <a:pPr algn="l">
+              <a:lnSpc>
+                <a:spcPct val="95000"/>
+              </a:lnSpc>
+              <a:spcAft>
+                <a:spcPts val="300"/>
+              </a:spcAft>
+            </a:pPr>
+            <a:r>
+              <a:rPr sz="1000" b="1">
                 <a:solidFill>
                   <a:srgbClr val="1B3037"/>
                 </a:solidFill>
@@ -4366,7 +4366,7 @@
         </p:nvSpPr>
         <p:spPr>
           <a:xfrm>
-            <a:off x="3520440" y="2240280"/>
+            <a:off x="3520440" y="2212848"/>
             <a:ext cx="1051560" cy="274320"/>
           </a:xfrm>
           <a:prstGeom prst="rect">
@@ -4389,7 +4389,7 @@
               </a:spcAft>
             </a:pPr>
             <a:r>
-              <a:rPr sz="1000" b="1">
+              <a:rPr sz="950" b="1">
                 <a:solidFill>
                   <a:srgbClr val="00B378"/>
                 </a:solidFill>
@@ -4408,30 +4408,30 @@
         </p:nvSpPr>
         <p:spPr>
           <a:xfrm>
-            <a:off x="4663440" y="2240280"/>
-            <a:ext cx="2834640" cy="329184"/>
-          </a:xfrm>
-          <a:prstGeom prst="rect">
-            <a:avLst/>
-          </a:prstGeom>
-          <a:noFill/>
-        </p:spPr>
-        <p:txBody>
-          <a:bodyPr wrap="square" anchor="t" lIns="0" rIns="0" tIns="0" bIns="0">
-            <a:spAutoFit/>
-          </a:bodyPr>
-          <a:lstStyle/>
-          <a:p>
-            <a:pPr algn="l">
-              <a:lnSpc>
-                <a:spcPct val="98000"/>
-              </a:lnSpc>
-              <a:spcAft>
-                <a:spcPts val="300"/>
-              </a:spcAft>
-            </a:pPr>
-            <a:r>
-              <a:rPr sz="900" b="0">
+            <a:off x="4663440" y="2212848"/>
+            <a:ext cx="2834640" cy="310896"/>
+          </a:xfrm>
+          <a:prstGeom prst="rect">
+            <a:avLst/>
+          </a:prstGeom>
+          <a:noFill/>
+        </p:spPr>
+        <p:txBody>
+          <a:bodyPr wrap="square" anchor="t" lIns="0" rIns="0" tIns="0" bIns="0">
+            <a:spAutoFit/>
+          </a:bodyPr>
+          <a:lstStyle/>
+          <a:p>
+            <a:pPr algn="l">
+              <a:lnSpc>
+                <a:spcPct val="95000"/>
+              </a:lnSpc>
+              <a:spcAft>
+                <a:spcPts val="300"/>
+              </a:spcAft>
+            </a:pPr>
+            <a:r>
+              <a:rPr sz="850" b="0">
                 <a:solidFill>
                   <a:srgbClr val="618793"/>
                 </a:solidFill>
@@ -4450,7 +4450,7 @@
         </p:nvSpPr>
         <p:spPr>
           <a:xfrm>
-            <a:off x="7635240" y="2240280"/>
+            <a:off x="7635240" y="2212848"/>
             <a:ext cx="1143000" cy="274320"/>
           </a:xfrm>
           <a:prstGeom prst="rect">
@@ -4473,7 +4473,7 @@
               </a:spcAft>
             </a:pPr>
             <a:r>
-              <a:rPr sz="900" b="0">
+              <a:rPr sz="850" b="0">
                 <a:solidFill>
                   <a:srgbClr val="1B5161"/>
                 </a:solidFill>
@@ -4492,7 +4492,7 @@
         </p:nvSpPr>
         <p:spPr>
           <a:xfrm>
-            <a:off x="548640" y="2587752"/>
+            <a:off x="548640" y="2519172"/>
             <a:ext cx="8046720" cy="10972"/>
           </a:xfrm>
           <a:prstGeom prst="rect">
@@ -4536,30 +4536,30 @@
         </p:nvSpPr>
         <p:spPr>
           <a:xfrm>
-            <a:off x="548640" y="2606040"/>
-            <a:ext cx="2834640" cy="329184"/>
-          </a:xfrm>
-          <a:prstGeom prst="rect">
-            <a:avLst/>
-          </a:prstGeom>
-          <a:noFill/>
-        </p:spPr>
-        <p:txBody>
-          <a:bodyPr wrap="square" anchor="t" lIns="0" rIns="0" tIns="0" bIns="0">
-            <a:spAutoFit/>
-          </a:bodyPr>
-          <a:lstStyle/>
-          <a:p>
-            <a:pPr algn="l">
-              <a:lnSpc>
-                <a:spcPct val="98000"/>
-              </a:lnSpc>
-              <a:spcAft>
-                <a:spcPts val="300"/>
-              </a:spcAft>
-            </a:pPr>
-            <a:r>
-              <a:rPr sz="1050" b="1">
+            <a:off x="548640" y="2531059"/>
+            <a:ext cx="2834640" cy="310896"/>
+          </a:xfrm>
+          <a:prstGeom prst="rect">
+            <a:avLst/>
+          </a:prstGeom>
+          <a:noFill/>
+        </p:spPr>
+        <p:txBody>
+          <a:bodyPr wrap="square" anchor="t" lIns="0" rIns="0" tIns="0" bIns="0">
+            <a:spAutoFit/>
+          </a:bodyPr>
+          <a:lstStyle/>
+          <a:p>
+            <a:pPr algn="l">
+              <a:lnSpc>
+                <a:spcPct val="95000"/>
+              </a:lnSpc>
+              <a:spcAft>
+                <a:spcPts val="300"/>
+              </a:spcAft>
+            </a:pPr>
+            <a:r>
+              <a:rPr sz="1000" b="1">
                 <a:solidFill>
                   <a:srgbClr val="1B3037"/>
                 </a:solidFill>
@@ -4578,7 +4578,7 @@
         </p:nvSpPr>
         <p:spPr>
           <a:xfrm>
-            <a:off x="3520440" y="2606040"/>
+            <a:off x="3520440" y="2531059"/>
             <a:ext cx="1051560" cy="274320"/>
           </a:xfrm>
           <a:prstGeom prst="rect">
@@ -4601,7 +4601,7 @@
               </a:spcAft>
             </a:pPr>
             <a:r>
-              <a:rPr sz="1000" b="1">
+              <a:rPr sz="950" b="1">
                 <a:solidFill>
                   <a:srgbClr val="00B378"/>
                 </a:solidFill>
@@ -4620,30 +4620,30 @@
         </p:nvSpPr>
         <p:spPr>
           <a:xfrm>
-            <a:off x="4663440" y="2606040"/>
-            <a:ext cx="2834640" cy="329184"/>
-          </a:xfrm>
-          <a:prstGeom prst="rect">
-            <a:avLst/>
-          </a:prstGeom>
-          <a:noFill/>
-        </p:spPr>
-        <p:txBody>
-          <a:bodyPr wrap="square" anchor="t" lIns="0" rIns="0" tIns="0" bIns="0">
-            <a:spAutoFit/>
-          </a:bodyPr>
-          <a:lstStyle/>
-          <a:p>
-            <a:pPr algn="l">
-              <a:lnSpc>
-                <a:spcPct val="98000"/>
-              </a:lnSpc>
-              <a:spcAft>
-                <a:spcPts val="300"/>
-              </a:spcAft>
-            </a:pPr>
-            <a:r>
-              <a:rPr sz="900" b="0">
+            <a:off x="4663440" y="2531059"/>
+            <a:ext cx="2834640" cy="310896"/>
+          </a:xfrm>
+          <a:prstGeom prst="rect">
+            <a:avLst/>
+          </a:prstGeom>
+          <a:noFill/>
+        </p:spPr>
+        <p:txBody>
+          <a:bodyPr wrap="square" anchor="t" lIns="0" rIns="0" tIns="0" bIns="0">
+            <a:spAutoFit/>
+          </a:bodyPr>
+          <a:lstStyle/>
+          <a:p>
+            <a:pPr algn="l">
+              <a:lnSpc>
+                <a:spcPct val="95000"/>
+              </a:lnSpc>
+              <a:spcAft>
+                <a:spcPts val="300"/>
+              </a:spcAft>
+            </a:pPr>
+            <a:r>
+              <a:rPr sz="850" b="0">
                 <a:solidFill>
                   <a:srgbClr val="618793"/>
                 </a:solidFill>
@@ -4662,7 +4662,7 @@
         </p:nvSpPr>
         <p:spPr>
           <a:xfrm>
-            <a:off x="7635240" y="2606040"/>
+            <a:off x="7635240" y="2531059"/>
             <a:ext cx="1143000" cy="274320"/>
           </a:xfrm>
           <a:prstGeom prst="rect">
@@ -4685,7 +4685,7 @@
               </a:spcAft>
             </a:pPr>
             <a:r>
-              <a:rPr sz="900" b="0">
+              <a:rPr sz="850" b="0">
                 <a:solidFill>
                   <a:srgbClr val="1B5161"/>
                 </a:solidFill>
@@ -4704,7 +4704,7 @@
         </p:nvSpPr>
         <p:spPr>
           <a:xfrm>
-            <a:off x="548640" y="2953512"/>
+            <a:off x="548640" y="2837383"/>
             <a:ext cx="8046720" cy="10972"/>
           </a:xfrm>
           <a:prstGeom prst="rect">
@@ -4748,30 +4748,30 @@
         </p:nvSpPr>
         <p:spPr>
           <a:xfrm>
-            <a:off x="548640" y="2971800"/>
-            <a:ext cx="2834640" cy="329184"/>
-          </a:xfrm>
-          <a:prstGeom prst="rect">
-            <a:avLst/>
-          </a:prstGeom>
-          <a:noFill/>
-        </p:spPr>
-        <p:txBody>
-          <a:bodyPr wrap="square" anchor="t" lIns="0" rIns="0" tIns="0" bIns="0">
-            <a:spAutoFit/>
-          </a:bodyPr>
-          <a:lstStyle/>
-          <a:p>
-            <a:pPr algn="l">
-              <a:lnSpc>
-                <a:spcPct val="98000"/>
-              </a:lnSpc>
-              <a:spcAft>
-                <a:spcPts val="300"/>
-              </a:spcAft>
-            </a:pPr>
-            <a:r>
-              <a:rPr sz="1050" b="1">
+            <a:off x="548640" y="2849270"/>
+            <a:ext cx="2834640" cy="310896"/>
+          </a:xfrm>
+          <a:prstGeom prst="rect">
+            <a:avLst/>
+          </a:prstGeom>
+          <a:noFill/>
+        </p:spPr>
+        <p:txBody>
+          <a:bodyPr wrap="square" anchor="t" lIns="0" rIns="0" tIns="0" bIns="0">
+            <a:spAutoFit/>
+          </a:bodyPr>
+          <a:lstStyle/>
+          <a:p>
+            <a:pPr algn="l">
+              <a:lnSpc>
+                <a:spcPct val="95000"/>
+              </a:lnSpc>
+              <a:spcAft>
+                <a:spcPts val="300"/>
+              </a:spcAft>
+            </a:pPr>
+            <a:r>
+              <a:rPr sz="1000" b="1">
                 <a:solidFill>
                   <a:srgbClr val="1B3037"/>
                 </a:solidFill>
@@ -4790,7 +4790,7 @@
         </p:nvSpPr>
         <p:spPr>
           <a:xfrm>
-            <a:off x="3520440" y="2971800"/>
+            <a:off x="3520440" y="2849270"/>
             <a:ext cx="1051560" cy="274320"/>
           </a:xfrm>
           <a:prstGeom prst="rect">
@@ -4813,7 +4813,7 @@
               </a:spcAft>
             </a:pPr>
             <a:r>
-              <a:rPr sz="1000" b="1">
+              <a:rPr sz="950" b="1">
                 <a:solidFill>
                   <a:srgbClr val="00B378"/>
                 </a:solidFill>
@@ -4832,30 +4832,30 @@
         </p:nvSpPr>
         <p:spPr>
           <a:xfrm>
-            <a:off x="4663440" y="2971800"/>
-            <a:ext cx="2834640" cy="329184"/>
-          </a:xfrm>
-          <a:prstGeom prst="rect">
-            <a:avLst/>
-          </a:prstGeom>
-          <a:noFill/>
-        </p:spPr>
-        <p:txBody>
-          <a:bodyPr wrap="square" anchor="t" lIns="0" rIns="0" tIns="0" bIns="0">
-            <a:spAutoFit/>
-          </a:bodyPr>
-          <a:lstStyle/>
-          <a:p>
-            <a:pPr algn="l">
-              <a:lnSpc>
-                <a:spcPct val="98000"/>
-              </a:lnSpc>
-              <a:spcAft>
-                <a:spcPts val="300"/>
-              </a:spcAft>
-            </a:pPr>
-            <a:r>
-              <a:rPr sz="900" b="0">
+            <a:off x="4663440" y="2849270"/>
+            <a:ext cx="2834640" cy="310896"/>
+          </a:xfrm>
+          <a:prstGeom prst="rect">
+            <a:avLst/>
+          </a:prstGeom>
+          <a:noFill/>
+        </p:spPr>
+        <p:txBody>
+          <a:bodyPr wrap="square" anchor="t" lIns="0" rIns="0" tIns="0" bIns="0">
+            <a:spAutoFit/>
+          </a:bodyPr>
+          <a:lstStyle/>
+          <a:p>
+            <a:pPr algn="l">
+              <a:lnSpc>
+                <a:spcPct val="95000"/>
+              </a:lnSpc>
+              <a:spcAft>
+                <a:spcPts val="300"/>
+              </a:spcAft>
+            </a:pPr>
+            <a:r>
+              <a:rPr sz="850" b="0">
                 <a:solidFill>
                   <a:srgbClr val="618793"/>
                 </a:solidFill>
@@ -4874,7 +4874,7 @@
         </p:nvSpPr>
         <p:spPr>
           <a:xfrm>
-            <a:off x="7635240" y="2971800"/>
+            <a:off x="7635240" y="2849270"/>
             <a:ext cx="1143000" cy="274320"/>
           </a:xfrm>
           <a:prstGeom prst="rect">
@@ -4897,7 +4897,7 @@
               </a:spcAft>
             </a:pPr>
             <a:r>
-              <a:rPr sz="900" b="0">
+              <a:rPr sz="850" b="0">
                 <a:solidFill>
                   <a:srgbClr val="1B5161"/>
                 </a:solidFill>
@@ -4916,7 +4916,7 @@
         </p:nvSpPr>
         <p:spPr>
           <a:xfrm>
-            <a:off x="548640" y="3319272"/>
+            <a:off x="548640" y="3155594"/>
             <a:ext cx="8046720" cy="10972"/>
           </a:xfrm>
           <a:prstGeom prst="rect">
@@ -4960,30 +4960,30 @@
         </p:nvSpPr>
         <p:spPr>
           <a:xfrm>
-            <a:off x="548640" y="3337560"/>
-            <a:ext cx="2834640" cy="329184"/>
-          </a:xfrm>
-          <a:prstGeom prst="rect">
-            <a:avLst/>
-          </a:prstGeom>
-          <a:noFill/>
-        </p:spPr>
-        <p:txBody>
-          <a:bodyPr wrap="square" anchor="t" lIns="0" rIns="0" tIns="0" bIns="0">
-            <a:spAutoFit/>
-          </a:bodyPr>
-          <a:lstStyle/>
-          <a:p>
-            <a:pPr algn="l">
-              <a:lnSpc>
-                <a:spcPct val="98000"/>
-              </a:lnSpc>
-              <a:spcAft>
-                <a:spcPts val="300"/>
-              </a:spcAft>
-            </a:pPr>
-            <a:r>
-              <a:rPr sz="1050" b="1">
+            <a:off x="548640" y="3167481"/>
+            <a:ext cx="2834640" cy="310896"/>
+          </a:xfrm>
+          <a:prstGeom prst="rect">
+            <a:avLst/>
+          </a:prstGeom>
+          <a:noFill/>
+        </p:spPr>
+        <p:txBody>
+          <a:bodyPr wrap="square" anchor="t" lIns="0" rIns="0" tIns="0" bIns="0">
+            <a:spAutoFit/>
+          </a:bodyPr>
+          <a:lstStyle/>
+          <a:p>
+            <a:pPr algn="l">
+              <a:lnSpc>
+                <a:spcPct val="95000"/>
+              </a:lnSpc>
+              <a:spcAft>
+                <a:spcPts val="300"/>
+              </a:spcAft>
+            </a:pPr>
+            <a:r>
+              <a:rPr sz="1000" b="1">
                 <a:solidFill>
                   <a:srgbClr val="1B3037"/>
                 </a:solidFill>
@@ -5002,7 +5002,7 @@
         </p:nvSpPr>
         <p:spPr>
           <a:xfrm>
-            <a:off x="3520440" y="3337560"/>
+            <a:off x="3520440" y="3167481"/>
             <a:ext cx="1051560" cy="274320"/>
           </a:xfrm>
           <a:prstGeom prst="rect">
@@ -5025,7 +5025,7 @@
               </a:spcAft>
             </a:pPr>
             <a:r>
-              <a:rPr sz="1000" b="1">
+              <a:rPr sz="950" b="1">
                 <a:solidFill>
                   <a:srgbClr val="00B378"/>
                 </a:solidFill>
@@ -5044,30 +5044,30 @@
         </p:nvSpPr>
         <p:spPr>
           <a:xfrm>
-            <a:off x="4663440" y="3337560"/>
-            <a:ext cx="2834640" cy="329184"/>
-          </a:xfrm>
-          <a:prstGeom prst="rect">
-            <a:avLst/>
-          </a:prstGeom>
-          <a:noFill/>
-        </p:spPr>
-        <p:txBody>
-          <a:bodyPr wrap="square" anchor="t" lIns="0" rIns="0" tIns="0" bIns="0">
-            <a:spAutoFit/>
-          </a:bodyPr>
-          <a:lstStyle/>
-          <a:p>
-            <a:pPr algn="l">
-              <a:lnSpc>
-                <a:spcPct val="98000"/>
-              </a:lnSpc>
-              <a:spcAft>
-                <a:spcPts val="300"/>
-              </a:spcAft>
-            </a:pPr>
-            <a:r>
-              <a:rPr sz="900" b="0">
+            <a:off x="4663440" y="3167481"/>
+            <a:ext cx="2834640" cy="310896"/>
+          </a:xfrm>
+          <a:prstGeom prst="rect">
+            <a:avLst/>
+          </a:prstGeom>
+          <a:noFill/>
+        </p:spPr>
+        <p:txBody>
+          <a:bodyPr wrap="square" anchor="t" lIns="0" rIns="0" tIns="0" bIns="0">
+            <a:spAutoFit/>
+          </a:bodyPr>
+          <a:lstStyle/>
+          <a:p>
+            <a:pPr algn="l">
+              <a:lnSpc>
+                <a:spcPct val="95000"/>
+              </a:lnSpc>
+              <a:spcAft>
+                <a:spcPts val="300"/>
+              </a:spcAft>
+            </a:pPr>
+            <a:r>
+              <a:rPr sz="850" b="0">
                 <a:solidFill>
                   <a:srgbClr val="618793"/>
                 </a:solidFill>
@@ -5086,7 +5086,7 @@
         </p:nvSpPr>
         <p:spPr>
           <a:xfrm>
-            <a:off x="7635240" y="3337560"/>
+            <a:off x="7635240" y="3167481"/>
             <a:ext cx="1143000" cy="274320"/>
           </a:xfrm>
           <a:prstGeom prst="rect">
@@ -5109,7 +5109,7 @@
               </a:spcAft>
             </a:pPr>
             <a:r>
-              <a:rPr sz="900" b="0">
+              <a:rPr sz="850" b="0">
                 <a:solidFill>
                   <a:srgbClr val="1B5161"/>
                 </a:solidFill>
@@ -5128,7 +5128,7 @@
         </p:nvSpPr>
         <p:spPr>
           <a:xfrm>
-            <a:off x="548640" y="3685032"/>
+            <a:off x="548640" y="3473805"/>
             <a:ext cx="8046720" cy="10972"/>
           </a:xfrm>
           <a:prstGeom prst="rect">
@@ -5172,30 +5172,30 @@
         </p:nvSpPr>
         <p:spPr>
           <a:xfrm>
-            <a:off x="548640" y="3703320"/>
-            <a:ext cx="2834640" cy="329184"/>
-          </a:xfrm>
-          <a:prstGeom prst="rect">
-            <a:avLst/>
-          </a:prstGeom>
-          <a:noFill/>
-        </p:spPr>
-        <p:txBody>
-          <a:bodyPr wrap="square" anchor="t" lIns="0" rIns="0" tIns="0" bIns="0">
-            <a:spAutoFit/>
-          </a:bodyPr>
-          <a:lstStyle/>
-          <a:p>
-            <a:pPr algn="l">
-              <a:lnSpc>
-                <a:spcPct val="98000"/>
-              </a:lnSpc>
-              <a:spcAft>
-                <a:spcPts val="300"/>
-              </a:spcAft>
-            </a:pPr>
-            <a:r>
-              <a:rPr sz="1050" b="1">
+            <a:off x="548640" y="3485692"/>
+            <a:ext cx="2834640" cy="310896"/>
+          </a:xfrm>
+          <a:prstGeom prst="rect">
+            <a:avLst/>
+          </a:prstGeom>
+          <a:noFill/>
+        </p:spPr>
+        <p:txBody>
+          <a:bodyPr wrap="square" anchor="t" lIns="0" rIns="0" tIns="0" bIns="0">
+            <a:spAutoFit/>
+          </a:bodyPr>
+          <a:lstStyle/>
+          <a:p>
+            <a:pPr algn="l">
+              <a:lnSpc>
+                <a:spcPct val="95000"/>
+              </a:lnSpc>
+              <a:spcAft>
+                <a:spcPts val="300"/>
+              </a:spcAft>
+            </a:pPr>
+            <a:r>
+              <a:rPr sz="1000" b="1">
                 <a:solidFill>
                   <a:srgbClr val="1B3037"/>
                 </a:solidFill>
@@ -5214,7 +5214,7 @@
         </p:nvSpPr>
         <p:spPr>
           <a:xfrm>
-            <a:off x="3520440" y="3703320"/>
+            <a:off x="3520440" y="3485692"/>
             <a:ext cx="1051560" cy="274320"/>
           </a:xfrm>
           <a:prstGeom prst="rect">
@@ -5237,7 +5237,7 @@
               </a:spcAft>
             </a:pPr>
             <a:r>
-              <a:rPr sz="1000" b="1">
+              <a:rPr sz="950" b="1">
                 <a:solidFill>
                   <a:srgbClr val="00B378"/>
                 </a:solidFill>
@@ -5256,30 +5256,30 @@
         </p:nvSpPr>
         <p:spPr>
           <a:xfrm>
-            <a:off x="4663440" y="3703320"/>
-            <a:ext cx="2834640" cy="329184"/>
-          </a:xfrm>
-          <a:prstGeom prst="rect">
-            <a:avLst/>
-          </a:prstGeom>
-          <a:noFill/>
-        </p:spPr>
-        <p:txBody>
-          <a:bodyPr wrap="square" anchor="t" lIns="0" rIns="0" tIns="0" bIns="0">
-            <a:spAutoFit/>
-          </a:bodyPr>
-          <a:lstStyle/>
-          <a:p>
-            <a:pPr algn="l">
-              <a:lnSpc>
-                <a:spcPct val="98000"/>
-              </a:lnSpc>
-              <a:spcAft>
-                <a:spcPts val="300"/>
-              </a:spcAft>
-            </a:pPr>
-            <a:r>
-              <a:rPr sz="900" b="0">
+            <a:off x="4663440" y="3485692"/>
+            <a:ext cx="2834640" cy="310896"/>
+          </a:xfrm>
+          <a:prstGeom prst="rect">
+            <a:avLst/>
+          </a:prstGeom>
+          <a:noFill/>
+        </p:spPr>
+        <p:txBody>
+          <a:bodyPr wrap="square" anchor="t" lIns="0" rIns="0" tIns="0" bIns="0">
+            <a:spAutoFit/>
+          </a:bodyPr>
+          <a:lstStyle/>
+          <a:p>
+            <a:pPr algn="l">
+              <a:lnSpc>
+                <a:spcPct val="95000"/>
+              </a:lnSpc>
+              <a:spcAft>
+                <a:spcPts val="300"/>
+              </a:spcAft>
+            </a:pPr>
+            <a:r>
+              <a:rPr sz="850" b="0">
                 <a:solidFill>
                   <a:srgbClr val="618793"/>
                 </a:solidFill>
@@ -5298,7 +5298,7 @@
         </p:nvSpPr>
         <p:spPr>
           <a:xfrm>
-            <a:off x="7635240" y="3703320"/>
+            <a:off x="7635240" y="3485692"/>
             <a:ext cx="1143000" cy="274320"/>
           </a:xfrm>
           <a:prstGeom prst="rect">
@@ -5321,7 +5321,7 @@
               </a:spcAft>
             </a:pPr>
             <a:r>
-              <a:rPr sz="900" b="0">
+              <a:rPr sz="850" b="0">
                 <a:solidFill>
                   <a:srgbClr val="1B5161"/>
                 </a:solidFill>
@@ -5340,7 +5340,7 @@
         </p:nvSpPr>
         <p:spPr>
           <a:xfrm>
-            <a:off x="548640" y="4050791"/>
+            <a:off x="548640" y="3792016"/>
             <a:ext cx="8046720" cy="10972"/>
           </a:xfrm>
           <a:prstGeom prst="rect">
@@ -5384,30 +5384,30 @@
         </p:nvSpPr>
         <p:spPr>
           <a:xfrm>
-            <a:off x="548640" y="4069080"/>
-            <a:ext cx="2834640" cy="329184"/>
-          </a:xfrm>
-          <a:prstGeom prst="rect">
-            <a:avLst/>
-          </a:prstGeom>
-          <a:noFill/>
-        </p:spPr>
-        <p:txBody>
-          <a:bodyPr wrap="square" anchor="t" lIns="0" rIns="0" tIns="0" bIns="0">
-            <a:spAutoFit/>
-          </a:bodyPr>
-          <a:lstStyle/>
-          <a:p>
-            <a:pPr algn="l">
-              <a:lnSpc>
-                <a:spcPct val="98000"/>
-              </a:lnSpc>
-              <a:spcAft>
-                <a:spcPts val="300"/>
-              </a:spcAft>
-            </a:pPr>
-            <a:r>
-              <a:rPr sz="1050" b="1">
+            <a:off x="548640" y="3803903"/>
+            <a:ext cx="2834640" cy="310896"/>
+          </a:xfrm>
+          <a:prstGeom prst="rect">
+            <a:avLst/>
+          </a:prstGeom>
+          <a:noFill/>
+        </p:spPr>
+        <p:txBody>
+          <a:bodyPr wrap="square" anchor="t" lIns="0" rIns="0" tIns="0" bIns="0">
+            <a:spAutoFit/>
+          </a:bodyPr>
+          <a:lstStyle/>
+          <a:p>
+            <a:pPr algn="l">
+              <a:lnSpc>
+                <a:spcPct val="95000"/>
+              </a:lnSpc>
+              <a:spcAft>
+                <a:spcPts val="300"/>
+              </a:spcAft>
+            </a:pPr>
+            <a:r>
+              <a:rPr sz="1000" b="1">
                 <a:solidFill>
                   <a:srgbClr val="1B3037"/>
                 </a:solidFill>
@@ -5426,7 +5426,7 @@
         </p:nvSpPr>
         <p:spPr>
           <a:xfrm>
-            <a:off x="3520440" y="4069080"/>
+            <a:off x="3520440" y="3803903"/>
             <a:ext cx="1051560" cy="274320"/>
           </a:xfrm>
           <a:prstGeom prst="rect">
@@ -5449,7 +5449,7 @@
               </a:spcAft>
             </a:pPr>
             <a:r>
-              <a:rPr sz="1000" b="1">
+              <a:rPr sz="950" b="1">
                 <a:solidFill>
                   <a:srgbClr val="00B378"/>
                 </a:solidFill>
@@ -5468,30 +5468,30 @@
         </p:nvSpPr>
         <p:spPr>
           <a:xfrm>
-            <a:off x="4663440" y="4069080"/>
-            <a:ext cx="2834640" cy="329184"/>
-          </a:xfrm>
-          <a:prstGeom prst="rect">
-            <a:avLst/>
-          </a:prstGeom>
-          <a:noFill/>
-        </p:spPr>
-        <p:txBody>
-          <a:bodyPr wrap="square" anchor="t" lIns="0" rIns="0" tIns="0" bIns="0">
-            <a:spAutoFit/>
-          </a:bodyPr>
-          <a:lstStyle/>
-          <a:p>
-            <a:pPr algn="l">
-              <a:lnSpc>
-                <a:spcPct val="98000"/>
-              </a:lnSpc>
-              <a:spcAft>
-                <a:spcPts val="300"/>
-              </a:spcAft>
-            </a:pPr>
-            <a:r>
-              <a:rPr sz="900" b="0">
+            <a:off x="4663440" y="3803903"/>
+            <a:ext cx="2834640" cy="310896"/>
+          </a:xfrm>
+          <a:prstGeom prst="rect">
+            <a:avLst/>
+          </a:prstGeom>
+          <a:noFill/>
+        </p:spPr>
+        <p:txBody>
+          <a:bodyPr wrap="square" anchor="t" lIns="0" rIns="0" tIns="0" bIns="0">
+            <a:spAutoFit/>
+          </a:bodyPr>
+          <a:lstStyle/>
+          <a:p>
+            <a:pPr algn="l">
+              <a:lnSpc>
+                <a:spcPct val="95000"/>
+              </a:lnSpc>
+              <a:spcAft>
+                <a:spcPts val="300"/>
+              </a:spcAft>
+            </a:pPr>
+            <a:r>
+              <a:rPr sz="850" b="0">
                 <a:solidFill>
                   <a:srgbClr val="618793"/>
                 </a:solidFill>
@@ -5510,7 +5510,7 @@
         </p:nvSpPr>
         <p:spPr>
           <a:xfrm>
-            <a:off x="7635240" y="4069080"/>
+            <a:off x="7635240" y="3803903"/>
             <a:ext cx="1143000" cy="274320"/>
           </a:xfrm>
           <a:prstGeom prst="rect">
@@ -5533,7 +5533,7 @@
               </a:spcAft>
             </a:pPr>
             <a:r>
-              <a:rPr sz="900" b="0">
+              <a:rPr sz="850" b="0">
                 <a:solidFill>
                   <a:srgbClr val="1B5161"/>
                 </a:solidFill>
@@ -5552,7 +5552,7 @@
         </p:nvSpPr>
         <p:spPr>
           <a:xfrm>
-            <a:off x="548640" y="4416552"/>
+            <a:off x="548640" y="4110227"/>
             <a:ext cx="8046720" cy="10972"/>
           </a:xfrm>
           <a:prstGeom prst="rect">
@@ -5596,36 +5596,36 @@
         </p:nvSpPr>
         <p:spPr>
           <a:xfrm>
-            <a:off x="548640" y="4434840"/>
-            <a:ext cx="2834640" cy="329184"/>
-          </a:xfrm>
-          <a:prstGeom prst="rect">
-            <a:avLst/>
-          </a:prstGeom>
-          <a:noFill/>
-        </p:spPr>
-        <p:txBody>
-          <a:bodyPr wrap="square" anchor="t" lIns="0" rIns="0" tIns="0" bIns="0">
-            <a:spAutoFit/>
-          </a:bodyPr>
-          <a:lstStyle/>
-          <a:p>
-            <a:pPr algn="l">
-              <a:lnSpc>
-                <a:spcPct val="98000"/>
-              </a:lnSpc>
-              <a:spcAft>
-                <a:spcPts val="300"/>
-              </a:spcAft>
-            </a:pPr>
-            <a:r>
-              <a:rPr sz="1050" b="1">
+            <a:off x="548640" y="4122115"/>
+            <a:ext cx="2834640" cy="310896"/>
+          </a:xfrm>
+          <a:prstGeom prst="rect">
+            <a:avLst/>
+          </a:prstGeom>
+          <a:noFill/>
+        </p:spPr>
+        <p:txBody>
+          <a:bodyPr wrap="square" anchor="t" lIns="0" rIns="0" tIns="0" bIns="0">
+            <a:spAutoFit/>
+          </a:bodyPr>
+          <a:lstStyle/>
+          <a:p>
+            <a:pPr algn="l">
+              <a:lnSpc>
+                <a:spcPct val="95000"/>
+              </a:lnSpc>
+              <a:spcAft>
+                <a:spcPts val="300"/>
+              </a:spcAft>
+            </a:pPr>
+            <a:r>
+              <a:rPr sz="1000" b="1">
                 <a:solidFill>
                   <a:srgbClr val="1B3037"/>
                 </a:solidFill>
                 <a:latin typeface="Barlow"/>
               </a:rPr>
-              <a:t>Scale / prod-volume</a:t>
+              <a:t>UC lineage trace-back + blast radius</a:t>
             </a:r>
           </a:p>
         </p:txBody>
@@ -5638,7 +5638,7 @@
         </p:nvSpPr>
         <p:spPr>
           <a:xfrm>
-            <a:off x="3520440" y="4434840"/>
+            <a:off x="3520440" y="4122115"/>
             <a:ext cx="1051560" cy="274320"/>
           </a:xfrm>
           <a:prstGeom prst="rect">
@@ -5661,7 +5661,7 @@
               </a:spcAft>
             </a:pPr>
             <a:r>
-              <a:rPr sz="1000" b="1">
+              <a:rPr sz="950" b="1">
                 <a:solidFill>
                   <a:srgbClr val="00B378"/>
                 </a:solidFill>
@@ -5680,36 +5680,36 @@
         </p:nvSpPr>
         <p:spPr>
           <a:xfrm>
-            <a:off x="4663440" y="4434840"/>
-            <a:ext cx="2834640" cy="329184"/>
-          </a:xfrm>
-          <a:prstGeom prst="rect">
-            <a:avLst/>
-          </a:prstGeom>
-          <a:noFill/>
-        </p:spPr>
-        <p:txBody>
-          <a:bodyPr wrap="square" anchor="t" lIns="0" rIns="0" tIns="0" bIns="0">
-            <a:spAutoFit/>
-          </a:bodyPr>
-          <a:lstStyle/>
-          <a:p>
-            <a:pPr algn="l">
-              <a:lnSpc>
-                <a:spcPct val="98000"/>
-              </a:lnSpc>
-              <a:spcAft>
-                <a:spcPts val="300"/>
-              </a:spcAft>
-            </a:pPr>
-            <a:r>
-              <a:rPr sz="900" b="0">
+            <a:off x="4663440" y="4122115"/>
+            <a:ext cx="2834640" cy="310896"/>
+          </a:xfrm>
+          <a:prstGeom prst="rect">
+            <a:avLst/>
+          </a:prstGeom>
+          <a:noFill/>
+        </p:spPr>
+        <p:txBody>
+          <a:bodyPr wrap="square" anchor="t" lIns="0" rIns="0" tIns="0" bIns="0">
+            <a:spAutoFit/>
+          </a:bodyPr>
+          <a:lstStyle/>
+          <a:p>
+            <a:pPr algn="l">
+              <a:lnSpc>
+                <a:spcPct val="95000"/>
+              </a:lnSpc>
+              <a:spcAft>
+                <a:spcPts val="300"/>
+              </a:spcAft>
+            </a:pPr>
+            <a:r>
+              <a:rPr sz="850" b="0">
                 <a:solidFill>
                   <a:srgbClr val="618793"/>
                 </a:solidFill>
                 <a:latin typeface="DM Sans"/>
               </a:rPr>
-              <a:t>50M rows · 8.5 GB reconciled + RCA</a:t>
+              <a:t>walks column/table lineage to the root; downstream consumers</a:t>
             </a:r>
           </a:p>
         </p:txBody>
@@ -5722,7 +5722,7 @@
         </p:nvSpPr>
         <p:spPr>
           <a:xfrm>
-            <a:off x="7635240" y="4434840"/>
+            <a:off x="7635240" y="4122115"/>
             <a:ext cx="1143000" cy="274320"/>
           </a:xfrm>
           <a:prstGeom prst="rect">
@@ -5745,13 +5745,13 @@
               </a:spcAft>
             </a:pPr>
             <a:r>
-              <a:rPr sz="900" b="0">
+              <a:rPr sz="850" b="0">
                 <a:solidFill>
                   <a:srgbClr val="1B5161"/>
                 </a:solidFill>
                 <a:latin typeface="DM Sans"/>
               </a:rPr>
-              <a:t>All</a:t>
+              <a:t>App·CLI·Skill</a:t>
             </a:r>
           </a:p>
         </p:txBody>
@@ -5764,7 +5764,7 @@
         </p:nvSpPr>
         <p:spPr>
           <a:xfrm>
-            <a:off x="548640" y="4782312"/>
+            <a:off x="548640" y="4428439"/>
             <a:ext cx="8046720" cy="10972"/>
           </a:xfrm>
           <a:prstGeom prst="rect">
@@ -5808,36 +5808,36 @@
         </p:nvSpPr>
         <p:spPr>
           <a:xfrm>
-            <a:off x="548640" y="4800600"/>
-            <a:ext cx="2834640" cy="329184"/>
-          </a:xfrm>
-          <a:prstGeom prst="rect">
-            <a:avLst/>
-          </a:prstGeom>
-          <a:noFill/>
-        </p:spPr>
-        <p:txBody>
-          <a:bodyPr wrap="square" anchor="t" lIns="0" rIns="0" tIns="0" bIns="0">
-            <a:spAutoFit/>
-          </a:bodyPr>
-          <a:lstStyle/>
-          <a:p>
-            <a:pPr algn="l">
-              <a:lnSpc>
-                <a:spcPct val="98000"/>
-              </a:lnSpc>
-              <a:spcAft>
-                <a:spcPts val="300"/>
-              </a:spcAft>
-            </a:pPr>
-            <a:r>
-              <a:rPr sz="1050" b="1">
+            <a:off x="548640" y="4440326"/>
+            <a:ext cx="2834640" cy="310896"/>
+          </a:xfrm>
+          <a:prstGeom prst="rect">
+            <a:avLst/>
+          </a:prstGeom>
+          <a:noFill/>
+        </p:spPr>
+        <p:txBody>
+          <a:bodyPr wrap="square" anchor="t" lIns="0" rIns="0" tIns="0" bIns="0">
+            <a:spAutoFit/>
+          </a:bodyPr>
+          <a:lstStyle/>
+          <a:p>
+            <a:pPr algn="l">
+              <a:lnSpc>
+                <a:spcPct val="95000"/>
+              </a:lnSpc>
+              <a:spcAft>
+                <a:spcPts val="300"/>
+              </a:spcAft>
+            </a:pPr>
+            <a:r>
+              <a:rPr sz="1000" b="1">
                 <a:solidFill>
                   <a:srgbClr val="1B3037"/>
                 </a:solidFill>
                 <a:latin typeface="Barlow"/>
               </a:rPr>
-              <a:t>Concurrency</a:t>
+              <a:t>Scale / prod-volume</a:t>
             </a:r>
           </a:p>
         </p:txBody>
@@ -5850,7 +5850,7 @@
         </p:nvSpPr>
         <p:spPr>
           <a:xfrm>
-            <a:off x="3520440" y="4800600"/>
+            <a:off x="3520440" y="4440326"/>
             <a:ext cx="1051560" cy="274320"/>
           </a:xfrm>
           <a:prstGeom prst="rect">
@@ -5873,7 +5873,7 @@
               </a:spcAft>
             </a:pPr>
             <a:r>
-              <a:rPr sz="1000" b="1">
+              <a:rPr sz="950" b="1">
                 <a:solidFill>
                   <a:srgbClr val="00B378"/>
                 </a:solidFill>
@@ -5892,36 +5892,36 @@
         </p:nvSpPr>
         <p:spPr>
           <a:xfrm>
-            <a:off x="4663440" y="4800600"/>
-            <a:ext cx="2834640" cy="329184"/>
-          </a:xfrm>
-          <a:prstGeom prst="rect">
-            <a:avLst/>
-          </a:prstGeom>
-          <a:noFill/>
-        </p:spPr>
-        <p:txBody>
-          <a:bodyPr wrap="square" anchor="t" lIns="0" rIns="0" tIns="0" bIns="0">
-            <a:spAutoFit/>
-          </a:bodyPr>
-          <a:lstStyle/>
-          <a:p>
-            <a:pPr algn="l">
-              <a:lnSpc>
-                <a:spcPct val="98000"/>
-              </a:lnSpc>
-              <a:spcAft>
-                <a:spcPts val="300"/>
-              </a:spcAft>
-            </a:pPr>
-            <a:r>
-              <a:rPr sz="900" b="0">
+            <a:off x="4663440" y="4440326"/>
+            <a:ext cx="2834640" cy="310896"/>
+          </a:xfrm>
+          <a:prstGeom prst="rect">
+            <a:avLst/>
+          </a:prstGeom>
+          <a:noFill/>
+        </p:spPr>
+        <p:txBody>
+          <a:bodyPr wrap="square" anchor="t" lIns="0" rIns="0" tIns="0" bIns="0">
+            <a:spAutoFit/>
+          </a:bodyPr>
+          <a:lstStyle/>
+          <a:p>
+            <a:pPr algn="l">
+              <a:lnSpc>
+                <a:spcPct val="95000"/>
+              </a:lnSpc>
+              <a:spcAft>
+                <a:spcPts val="300"/>
+              </a:spcAft>
+            </a:pPr>
+            <a:r>
+              <a:rPr sz="850" b="0">
                 <a:solidFill>
                   <a:srgbClr val="618793"/>
                 </a:solidFill>
                 <a:latin typeface="DM Sans"/>
               </a:rPr>
-              <a:t>6 concurrent runs · ~500 s wall</a:t>
+              <a:t>50M rows · 8.5 GB reconciled + RCA</a:t>
             </a:r>
           </a:p>
         </p:txBody>
@@ -5934,7 +5934,7 @@
         </p:nvSpPr>
         <p:spPr>
           <a:xfrm>
-            <a:off x="7635240" y="4800600"/>
+            <a:off x="7635240" y="4440326"/>
             <a:ext cx="1143000" cy="274320"/>
           </a:xfrm>
           <a:prstGeom prst="rect">
@@ -5957,7 +5957,7 @@
               </a:spcAft>
             </a:pPr>
             <a:r>
-              <a:rPr sz="900" b="0">
+              <a:rPr sz="850" b="0">
                 <a:solidFill>
                   <a:srgbClr val="1B5161"/>
                 </a:solidFill>
@@ -5976,7 +5976,219 @@
         </p:nvSpPr>
         <p:spPr>
           <a:xfrm>
-            <a:off x="548640" y="5148072"/>
+            <a:off x="548640" y="4746650"/>
+            <a:ext cx="8046720" cy="10972"/>
+          </a:xfrm>
+          <a:prstGeom prst="rect">
+            <a:avLst/>
+          </a:prstGeom>
+          <a:solidFill>
+            <a:srgbClr val="F1F1F1"/>
+          </a:solidFill>
+          <a:ln>
+            <a:noFill/>
+          </a:ln>
+          <a:effectLst/>
+        </p:spPr>
+        <p:style>
+          <a:lnRef idx="1">
+            <a:schemeClr val="accent1"/>
+          </a:lnRef>
+          <a:fillRef idx="3">
+            <a:schemeClr val="accent1"/>
+          </a:fillRef>
+          <a:effectRef idx="2">
+            <a:schemeClr val="accent1"/>
+          </a:effectRef>
+          <a:fontRef idx="minor">
+            <a:schemeClr val="lt1"/>
+          </a:fontRef>
+        </p:style>
+        <p:txBody>
+          <a:bodyPr rtlCol="0" anchor="ctr"/>
+          <a:lstStyle/>
+          <a:p>
+            <a:pPr algn="ctr"/>
+          </a:p>
+        </p:txBody>
+      </p:sp>
+      <p:sp>
+        <p:nvSpPr>
+          <p:cNvPr id="51" name="TextBox 50"/>
+          <p:cNvSpPr txBox="1"/>
+          <p:nvPr/>
+        </p:nvSpPr>
+        <p:spPr>
+          <a:xfrm>
+            <a:off x="548640" y="4758537"/>
+            <a:ext cx="2834640" cy="310896"/>
+          </a:xfrm>
+          <a:prstGeom prst="rect">
+            <a:avLst/>
+          </a:prstGeom>
+          <a:noFill/>
+        </p:spPr>
+        <p:txBody>
+          <a:bodyPr wrap="square" anchor="t" lIns="0" rIns="0" tIns="0" bIns="0">
+            <a:spAutoFit/>
+          </a:bodyPr>
+          <a:lstStyle/>
+          <a:p>
+            <a:pPr algn="l">
+              <a:lnSpc>
+                <a:spcPct val="95000"/>
+              </a:lnSpc>
+              <a:spcAft>
+                <a:spcPts val="300"/>
+              </a:spcAft>
+            </a:pPr>
+            <a:r>
+              <a:rPr sz="1000" b="1">
+                <a:solidFill>
+                  <a:srgbClr val="1B3037"/>
+                </a:solidFill>
+                <a:latin typeface="Barlow"/>
+              </a:rPr>
+              <a:t>Concurrency</a:t>
+            </a:r>
+          </a:p>
+        </p:txBody>
+      </p:sp>
+      <p:sp>
+        <p:nvSpPr>
+          <p:cNvPr id="52" name="TextBox 51"/>
+          <p:cNvSpPr txBox="1"/>
+          <p:nvPr/>
+        </p:nvSpPr>
+        <p:spPr>
+          <a:xfrm>
+            <a:off x="3520440" y="4758537"/>
+            <a:ext cx="1051560" cy="274320"/>
+          </a:xfrm>
+          <a:prstGeom prst="rect">
+            <a:avLst/>
+          </a:prstGeom>
+          <a:noFill/>
+        </p:spPr>
+        <p:txBody>
+          <a:bodyPr wrap="square" anchor="t" lIns="0" rIns="0" tIns="0" bIns="0">
+            <a:spAutoFit/>
+          </a:bodyPr>
+          <a:lstStyle/>
+          <a:p>
+            <a:pPr algn="l">
+              <a:lnSpc>
+                <a:spcPct val="100000"/>
+              </a:lnSpc>
+              <a:spcAft>
+                <a:spcPts val="300"/>
+              </a:spcAft>
+            </a:pPr>
+            <a:r>
+              <a:rPr sz="950" b="1">
+                <a:solidFill>
+                  <a:srgbClr val="00B378"/>
+                </a:solidFill>
+                <a:latin typeface="Barlow"/>
+              </a:rPr>
+              <a:t>✅ Works</a:t>
+            </a:r>
+          </a:p>
+        </p:txBody>
+      </p:sp>
+      <p:sp>
+        <p:nvSpPr>
+          <p:cNvPr id="53" name="TextBox 52"/>
+          <p:cNvSpPr txBox="1"/>
+          <p:nvPr/>
+        </p:nvSpPr>
+        <p:spPr>
+          <a:xfrm>
+            <a:off x="4663440" y="4758537"/>
+            <a:ext cx="2834640" cy="310896"/>
+          </a:xfrm>
+          <a:prstGeom prst="rect">
+            <a:avLst/>
+          </a:prstGeom>
+          <a:noFill/>
+        </p:spPr>
+        <p:txBody>
+          <a:bodyPr wrap="square" anchor="t" lIns="0" rIns="0" tIns="0" bIns="0">
+            <a:spAutoFit/>
+          </a:bodyPr>
+          <a:lstStyle/>
+          <a:p>
+            <a:pPr algn="l">
+              <a:lnSpc>
+                <a:spcPct val="95000"/>
+              </a:lnSpc>
+              <a:spcAft>
+                <a:spcPts val="300"/>
+              </a:spcAft>
+            </a:pPr>
+            <a:r>
+              <a:rPr sz="850" b="0">
+                <a:solidFill>
+                  <a:srgbClr val="618793"/>
+                </a:solidFill>
+                <a:latin typeface="DM Sans"/>
+              </a:rPr>
+              <a:t>6 concurrent runs · ~500 s wall</a:t>
+            </a:r>
+          </a:p>
+        </p:txBody>
+      </p:sp>
+      <p:sp>
+        <p:nvSpPr>
+          <p:cNvPr id="54" name="TextBox 53"/>
+          <p:cNvSpPr txBox="1"/>
+          <p:nvPr/>
+        </p:nvSpPr>
+        <p:spPr>
+          <a:xfrm>
+            <a:off x="7635240" y="4758537"/>
+            <a:ext cx="1143000" cy="274320"/>
+          </a:xfrm>
+          <a:prstGeom prst="rect">
+            <a:avLst/>
+          </a:prstGeom>
+          <a:noFill/>
+        </p:spPr>
+        <p:txBody>
+          <a:bodyPr wrap="square" anchor="t" lIns="0" rIns="0" tIns="0" bIns="0">
+            <a:spAutoFit/>
+          </a:bodyPr>
+          <a:lstStyle/>
+          <a:p>
+            <a:pPr algn="l">
+              <a:lnSpc>
+                <a:spcPct val="100000"/>
+              </a:lnSpc>
+              <a:spcAft>
+                <a:spcPts val="300"/>
+              </a:spcAft>
+            </a:pPr>
+            <a:r>
+              <a:rPr sz="850" b="0">
+                <a:solidFill>
+                  <a:srgbClr val="1B5161"/>
+                </a:solidFill>
+                <a:latin typeface="DM Sans"/>
+              </a:rPr>
+              <a:t>All</a:t>
+            </a:r>
+          </a:p>
+        </p:txBody>
+      </p:sp>
+      <p:sp>
+        <p:nvSpPr>
+          <p:cNvPr id="55" name="Rectangle 54"/>
+          <p:cNvSpPr/>
+          <p:nvPr/>
+        </p:nvSpPr>
+        <p:spPr>
+          <a:xfrm>
+            <a:off x="548640" y="5064861"/>
             <a:ext cx="8046720" cy="10972"/>
           </a:xfrm>
           <a:prstGeom prst="rect">

</xml_diff>